<commit_message>
Publish recorded shopping demo and recover confirmed x402 payments
</commit_message>
<xml_diff>
--- a/output/OY-Orders-agent-pitch.pptx
+++ b/output/OY-Orders-agent-pitch.pptx
@@ -587,7 +587,7 @@
           <a:lstStyle xmlns:a="http://schemas.openxmlformats.org/drawingml/2006/main"/>
           <a:p xmlns:a="http://schemas.openxmlformats.org/drawingml/2006/main">
             <a:r>
-              <a:t>The embedded movie is an edited tour of authentic app captures with synthetic narration. It is not a continuous screen recording of the entire purchase. The shopping purchase really paid on Cardano preprod and settled on Solana Devnet after eleven official CRE simulation checks. The signed false-fee demonstration and paid rejection/refund evidence are separate executions. The OY catalog deliberately includes bad test deals. It is not an autonomous LLM or an independent merchant marketplace. Evidence: https://oy-orders.vercel.app/api/orders/e63c7700-2bc4-4fe6-adca-a3074149120c/evidence and docs/evidence/STATUS.md.</a:t>
+              <a:t>The embedded movie is 89.02 seconds of edited actual public-app screen recording with synthetic narration. It shows a real goal/budget comparison, the same actual Cardano preprod purchase and Solana Devnet settlement, eleven official CRE checks, pass use and duplicate refusal. Pauses and chain confirmation waits are shortened. This recorded order 4b722b39-0a23-41de-a60b-ab977f16cd98 required operator-assisted recovery of the exact already-confirmed payment after an HTTP402 response; no second purchase. The automatic recovery code is now repaired. The older expired checkout is excluded from all movie footage. The catalog is OY-operated, the selection is deterministic policy and the voucher does not buy real coffee. Evidence: https://oy-orders.vercel.app/api/orders/4b722b39-0a23-41de-a60b-ab977f16cd98/evidence and docs/evidence/STATUS.md.</a:t>
             </a:r>
           </a:p>
         </p:txBody>
@@ -727,7 +727,7 @@
           <a:lstStyle xmlns:a="http://schemas.openxmlformats.org/drawingml/2006/main"/>
           <a:p xmlns:a="http://schemas.openxmlformats.org/drawingml/2006/main">
             <a:r>
-              <a:t>65 meaningful tests passed on 7 October, including the compiled Solana program in LiteSVM, quote policy, signed shopping plan selection and commitment tamper rejection, browser/Node signature parity, strict eleven-check CRE parsing, payment binding, recovery and atomic pass use. Nine genuine paid testnet orders: eight settled, one signed false reporting delivery rejected with same-order task reward refunded. One separate paused funding attempt had no escrow or supplier payment and is excluded. Latest shopping order e63c7700-2bc4-4fe6-adca-a3074149120c passed eleven checks and its first pass use was accepted. Earlier orders have ten checks. Sources: docs/evidence/STATUS.md, shopping-order.json and shopping-budget.json. Prototype uses official CRE simulation, trusted relayer, common supplier operator and free cloud quotas.</a:t>
+              <a:t>69 meaningful tests and type checking pass. 12 actual paid testnet orders: 10 settled, 1 signed false-report rejection with its task reward refunded, and 1 earlier payment-response-error order that expired without delivery and had its separate task reward refunded. Both Cardano supplier purchases remain final. The older expired checkout is not in the movie. Recorded shopping order 4b722b39-0a23-41de-a60b-ab977f16cd98 passed 11/11 official CRE checks after operator-assisted recovery of its confirmed payment, then accepted first use and refused replay. Official CRE simulation, trusted relayer, operator-owned test coins and OY supplier catalog. Supporting evidence: docs/evidence/recorded-shopping-order.json, recorded-shopping-video.json, expired-payment-error.json and STATUS.md.</a:t>
             </a:r>
           </a:p>
         </p:txBody>
@@ -3316,7 +3316,7 @@
                 <a:ea typeface="Arial"/>
                 <a:cs typeface="Arial"/>
               </a:rPr>
-              <a:t>65</a:t>
+              <a:t>69</a:t>
             </a:r>
           </a:p>
         </p:txBody>
@@ -3647,7 +3647,7 @@
                 <a:ea typeface="Arial"/>
                 <a:cs typeface="Arial"/>
               </a:rPr>
-              <a:t>9 paid testnet orders</a:t>
+              <a:t>12 paid testnet orders</a:t>
             </a:r>
           </a:p>
         </p:txBody>
@@ -3704,7 +3704,7 @@
                 <a:ea typeface="Arial"/>
                 <a:cs typeface="Arial"/>
               </a:rPr>
-              <a:t>8 settled. 1 rejected with reward refunded.</a:t>
+              <a:t>10 settled. 2 task rewards refunded.</a:t>
             </a:r>
           </a:p>
         </p:txBody>

</xml_diff>